<commit_message>
preview_view by textfield v1
</commit_message>
<xml_diff>
--- a/test/a.pptx
+++ b/test/a.pptx
@@ -8,6 +8,7 @@
     <p:sldId id="256" r:id="rId7"/>
     <p:sldId id="257" r:id="rId8"/>
     <p:sldId id="258" r:id="rId9"/>
+    <p:sldId id="259" r:id="rId10"/>
   </p:sldIdLst>
   <p:sldSz cx="12192000" cy="6858000" type="screen4x3"/>
   <p:notesSz cx="6858000" cy="9144000"/>
@@ -3156,7 +3157,7 @@
           </a:bodyPr>
           <a:lstStyle/>
           <a:p>
-            <a:pPr algn="dist"/>
+            <a:pPr algn="just"/>
             <a:r>
               <a:rPr sz="3200" b="0" i="0" u="none">
                 <a:solidFill>
@@ -3180,8 +3181,7 @@
 Khói sương bay - như dáng em ngày đó
 Chiếc áo len, tay lạnh nép vào anh
 Phố dốc xưa, giọt mưa trôi như nhớ
-Từng bước chân , giờ hóa chuyện xa xăm...hơ hờ hơ hơ Đà Lạt ơi
-Đà Lạt còn mưa không em ?</a:t>
+Từng bước chân , giờ hóa chuyện xa xăm...hơ hờ hơ hơ Đà Lạt ơi</a:t>
             </a:r>
           </a:p>
         </p:txBody>
@@ -3234,7 +3234,7 @@
           </a:bodyPr>
           <a:lstStyle/>
           <a:p>
-            <a:pPr algn="dist"/>
+            <a:pPr algn="just"/>
             <a:r>
               <a:rPr sz="3200" b="0" i="0" u="none">
                 <a:solidFill>
@@ -3242,17 +3242,14 @@
                 </a:solidFill>
                 <a:latin typeface="Times New Roman"/>
               </a:rPr>
-              <a:t>Còn ai đứng lặng bên thềm, đợi ai...
+              <a:t>
+Đà Lạt còn mưa không em ?
+Còn ai đứng lặng bên thềm, đợi ai...
 Bên hàng thông xưa em từng ngồi
 Giờ ai chạm khẽ, bàn tay phai phôi
 Đà Lạt còn sương không em ?
 Gió có còn gọi tên em giữa đêm
-Nếu ngày ấy mình, mình đừng lặng im
-Có lẽ giờ này, ..vẫn còn bên nhau..hờhơhờhớ hơhờhơhơhớ-----
-Có con đường anh chưa đi lại lần hai
-Sợ thấy những ký ức không phai
-Mùi hoa Mimosa lạc trong gió
-Như câu chuyện mình - chỉ còn để đó</a:t>
+Nếu ngày ấy mình, mình đừng lặng im</a:t>
             </a:r>
           </a:p>
         </p:txBody>
@@ -3305,7 +3302,7 @@
           </a:bodyPr>
           <a:lstStyle/>
           <a:p>
-            <a:pPr algn="dist"/>
+            <a:pPr algn="just"/>
             <a:r>
               <a:rPr sz="3200" b="0" i="0" u="none">
                 <a:solidFill>
@@ -3313,9 +3310,74 @@
                 </a:solidFill>
                 <a:latin typeface="Times New Roman"/>
               </a:rPr>
-              <a:t>Đêm Đà Lạt lạnh hơn khi không có em
-Tiếng xe máy khuya xa mờ trong đêm
-Lòng bỗng nhớ...dù không mong nữa
+              <a:t>Có lẽ giờ này, ..vẫn còn bên nhau..hờhơhờhớ hơhờhơhơhớ-----
+Có con đường anh chưa đi lại lần hai
+Sợ thấy những ký ức không phai
+Mùi hoa Mimosa lạc trong gió
+Như câu chuyện mình - chỉ còn để đó
+Đêm Đà Lạt lạnh hơn khi không có em
+Tiếng xe máy khuya xa mờ trong đêm</a:t>
+            </a:r>
+          </a:p>
+        </p:txBody>
+      </p:sp>
+    </p:spTree>
+  </p:cSld>
+  <p:clrMapOvr>
+    <a:masterClrMapping/>
+  </p:clrMapOvr>
+</p:sld>
+</file>
+
+<file path=ppt/slides/slide4.xml><?xml version="1.0" encoding="utf-8"?>
+<p:sld xmlns:a="http://schemas.openxmlformats.org/drawingml/2006/main" xmlns:p="http://schemas.openxmlformats.org/presentationml/2006/main" xmlns:r="http://schemas.openxmlformats.org/officeDocument/2006/relationships">
+  <p:cSld>
+    <p:bg>
+      <p:bgPr>
+        <a:solidFill>
+          <a:srgbClr val="5500FF"/>
+        </a:solidFill>
+        <a:effectLst/>
+      </p:bgPr>
+    </p:bg>
+    <p:spTree>
+      <p:nvGrpSpPr>
+        <p:cNvPr id="1" name=""/>
+        <p:cNvGrpSpPr/>
+        <p:nvPr/>
+      </p:nvGrpSpPr>
+      <p:grpSpPr/>
+      <p:sp>
+        <p:nvSpPr>
+          <p:cNvPr id="2" name="TextBox 1"/>
+          <p:cNvSpPr txBox="1"/>
+          <p:nvPr/>
+        </p:nvSpPr>
+        <p:spPr>
+          <a:xfrm>
+            <a:off x="0" y="0"/>
+            <a:ext cx="12191695" cy="6858000"/>
+          </a:xfrm>
+          <a:prstGeom prst="rect">
+            <a:avLst/>
+          </a:prstGeom>
+          <a:noFill/>
+        </p:spPr>
+        <p:txBody>
+          <a:bodyPr wrap="square">
+            <a:spAutoFit/>
+          </a:bodyPr>
+          <a:lstStyle/>
+          <a:p>
+            <a:pPr algn="just"/>
+            <a:r>
+              <a:rPr sz="3200" b="0" i="0" u="none">
+                <a:solidFill>
+                  <a:srgbClr val="FFFFFF"/>
+                </a:solidFill>
+                <a:latin typeface="Times New Roman"/>
+              </a:rPr>
+              <a:t>Lòng bỗng nhớ...dù không mong nữa
 Chỉ là... chợt nghe tiếng
 chuông ngân...buồn thêm...hơhờhơ em còn nhớ không?</a:t>
             </a:r>

</xml_diff>